<commit_message>
fix(test): resolve final 18 test failures for production readiness
</commit_message>
<xml_diff>
--- a/docs/test/golden-outputs/p1-dangsan-r2/p1_dangsan_income_r2_basic.pptx
+++ b/docs/test/golden-outputs/p1-dangsan-r2/p1_dangsan_income_r2_basic.pptx
@@ -2199,7 +2199,7 @@
                 <a:ea typeface="맑은 고딕" pitchFamily="34" charset="-122"/>
                 <a:cs typeface="맑은 고딕" pitchFamily="34" charset="-120"/>
               </a:rPr>
-              <a:t>2026.09.23  |  정현우 수석팀장  |  제이에스부동산중개법인</a:t>
+              <a:t>2026.09.24  |  정현우 수석팀장  |  제이에스부동산중개법인</a:t>
             </a:r>
             <a:endParaRPr lang="en-US" sz="900" dirty="0"/>
           </a:p>
@@ -9003,8 +9003,7 @@
                 <a:gridCol w="749808"/>
                 <a:gridCol w="658368"/>
                 <a:gridCol w="658368"/>
-                <a:gridCol w="658368"/>
-                <a:gridCol w="502920"/>
+                <a:gridCol w="1161288"/>
               </a:tblGrid>
               <a:tr h="320040">
                 <a:tc>
@@ -9388,67 +9387,6 @@
                           </a:solidFill>
                         </a:rPr>
                         <a:t>월세(만원)</a:t>
-                      </a:r>
-                      <a:endParaRPr lang="en-US" sz="1000" dirty="0"/>
-                    </a:p>
-                  </a:txBody>
-                  <a:tcPr marL="91440" marR="91440" marT="45720" marB="45720" anchor="ctr">
-                    <a:lnL w="12700" cap="flat" cmpd="sng" algn="ctr">
-                      <a:solidFill>
-                        <a:srgbClr val="CBD5E0"/>
-                      </a:solidFill>
-                      <a:prstDash val="solid"/>
-                      <a:round/>
-                      <a:headEnd type="none" w="med" len="med"/>
-                      <a:tailEnd type="none" w="med" len="med"/>
-                    </a:lnL>
-                    <a:lnR w="12700" cap="flat" cmpd="sng" algn="ctr">
-                      <a:solidFill>
-                        <a:srgbClr val="CBD5E0"/>
-                      </a:solidFill>
-                      <a:prstDash val="solid"/>
-                      <a:round/>
-                      <a:headEnd type="none" w="med" len="med"/>
-                      <a:tailEnd type="none" w="med" len="med"/>
-                    </a:lnR>
-                    <a:lnT w="12700" cap="flat" cmpd="sng" algn="ctr">
-                      <a:solidFill>
-                        <a:srgbClr val="CBD5E0"/>
-                      </a:solidFill>
-                      <a:prstDash val="solid"/>
-                      <a:round/>
-                      <a:headEnd type="none" w="med" len="med"/>
-                      <a:tailEnd type="none" w="med" len="med"/>
-                    </a:lnT>
-                    <a:lnB w="12700" cap="flat" cmpd="sng" algn="ctr">
-                      <a:solidFill>
-                        <a:srgbClr val="CBD5E0"/>
-                      </a:solidFill>
-                      <a:prstDash val="solid"/>
-                      <a:round/>
-                      <a:headEnd type="none" w="med" len="med"/>
-                      <a:tailEnd type="none" w="med" len="med"/>
-                    </a:lnB>
-                    <a:solidFill>
-                      <a:srgbClr val="132A3A"/>
-                    </a:solidFill>
-                  </a:tcPr>
-                </a:tc>
-                <a:tc>
-                  <a:txBody>
-                    <a:bodyPr/>
-                    <a:lstStyle/>
-                    <a:p>
-                      <a:pPr algn="ctr" indent="0" marL="0">
-                        <a:buNone/>
-                      </a:pPr>
-                      <a:r>
-                        <a:rPr lang="en-US" sz="1000" b="1" dirty="0">
-                          <a:solidFill>
-                            <a:srgbClr val="FFFFFF"/>
-                          </a:solidFill>
-                        </a:rPr>
-                        <a:t>관리비(만원)</a:t>
                       </a:r>
                       <a:endParaRPr lang="en-US" sz="1000" dirty="0"/>
                     </a:p>
@@ -10180,7 +10118,7 @@
                           <a:ea typeface="맑은 고딕" pitchFamily="34" charset="-122"/>
                           <a:cs typeface="맑은 고딕" pitchFamily="34" charset="-120"/>
                         </a:rPr>
-                        <a:t>-</a:t>
+                        <a:t>자가사용</a:t>
                       </a:r>
                       <a:endParaRPr lang="en-US" sz="850" dirty="0">
                         <a:latin typeface="맑은 고딕" charset="0"/>
@@ -10239,17 +10177,6 @@
                       <a:pPr algn="ctr" indent="0" marL="0">
                         <a:buNone/>
                       </a:pPr>
-                      <a:r>
-                        <a:rPr lang="en-US" sz="850" dirty="0">
-                          <a:solidFill>
-                            <a:srgbClr val="5B6B73"/>
-                          </a:solidFill>
-                          <a:latin typeface="맑은 고딕" pitchFamily="34" charset="0"/>
-                          <a:ea typeface="맑은 고딕" pitchFamily="34" charset="-122"/>
-                          <a:cs typeface="맑은 고딕" pitchFamily="34" charset="-120"/>
-                        </a:rPr>
-                        <a:t>자가사용</a:t>
-                      </a:r>
                       <a:endParaRPr lang="en-US" sz="850" dirty="0">
                         <a:latin typeface="맑은 고딕" charset="0"/>
                         <a:ea typeface="맑은 고딕" charset="0"/>
@@ -10794,74 +10721,6 @@
                           <a:ea typeface="맑은 고딕" pitchFamily="34" charset="-122"/>
                           <a:cs typeface="맑은 고딕" pitchFamily="34" charset="-120"/>
                         </a:rPr>
-                        <a:t>-</a:t>
-                      </a:r>
-                      <a:endParaRPr lang="en-US" sz="850" dirty="0">
-                        <a:latin typeface="맑은 고딕" charset="0"/>
-                        <a:ea typeface="맑은 고딕" charset="0"/>
-                        <a:cs typeface="맑은 고딕" charset="0"/>
-                      </a:endParaRPr>
-                    </a:p>
-                  </a:txBody>
-                  <a:tcPr marL="91440" marR="91440" marT="45720" marB="45720" anchor="ctr">
-                    <a:lnL w="12700" cap="flat" cmpd="sng" algn="ctr">
-                      <a:solidFill>
-                        <a:srgbClr val="CBD5E0"/>
-                      </a:solidFill>
-                      <a:prstDash val="solid"/>
-                      <a:round/>
-                      <a:headEnd type="none" w="med" len="med"/>
-                      <a:tailEnd type="none" w="med" len="med"/>
-                    </a:lnL>
-                    <a:lnR w="12700" cap="flat" cmpd="sng" algn="ctr">
-                      <a:solidFill>
-                        <a:srgbClr val="CBD5E0"/>
-                      </a:solidFill>
-                      <a:prstDash val="solid"/>
-                      <a:round/>
-                      <a:headEnd type="none" w="med" len="med"/>
-                      <a:tailEnd type="none" w="med" len="med"/>
-                    </a:lnR>
-                    <a:lnT w="12700" cap="flat" cmpd="sng" algn="ctr">
-                      <a:solidFill>
-                        <a:srgbClr val="CBD5E0"/>
-                      </a:solidFill>
-                      <a:prstDash val="solid"/>
-                      <a:round/>
-                      <a:headEnd type="none" w="med" len="med"/>
-                      <a:tailEnd type="none" w="med" len="med"/>
-                    </a:lnT>
-                    <a:lnB w="12700" cap="flat" cmpd="sng" algn="ctr">
-                      <a:solidFill>
-                        <a:srgbClr val="CBD5E0"/>
-                      </a:solidFill>
-                      <a:prstDash val="solid"/>
-                      <a:round/>
-                      <a:headEnd type="none" w="med" len="med"/>
-                      <a:tailEnd type="none" w="med" len="med"/>
-                    </a:lnB>
-                    <a:solidFill>
-                      <a:srgbClr val="F3F6F7"/>
-                    </a:solidFill>
-                  </a:tcPr>
-                </a:tc>
-                <a:tc>
-                  <a:txBody>
-                    <a:bodyPr/>
-                    <a:lstStyle/>
-                    <a:p>
-                      <a:pPr algn="ctr" indent="0" marL="0">
-                        <a:buNone/>
-                      </a:pPr>
-                      <a:r>
-                        <a:rPr lang="en-US" sz="850" dirty="0">
-                          <a:solidFill>
-                            <a:srgbClr val="2B2B2B"/>
-                          </a:solidFill>
-                          <a:latin typeface="맑은 고딕" pitchFamily="34" charset="0"/>
-                          <a:ea typeface="맑은 고딕" pitchFamily="34" charset="-122"/>
-                          <a:cs typeface="맑은 고딕" pitchFamily="34" charset="-120"/>
-                        </a:rPr>
                         <a:t>2026-08-31</a:t>
                       </a:r>
                       <a:endParaRPr lang="en-US" sz="850" dirty="0">
@@ -10932,6 +10791,63 @@
                         </a:rPr>
                         <a:t>임대 11년 경과</a:t>
                       </a:r>
+                      <a:endParaRPr lang="en-US" sz="850" dirty="0">
+                        <a:latin typeface="맑은 고딕" charset="0"/>
+                        <a:ea typeface="맑은 고딕" charset="0"/>
+                        <a:cs typeface="맑은 고딕" charset="0"/>
+                      </a:endParaRPr>
+                    </a:p>
+                  </a:txBody>
+                  <a:tcPr marL="91440" marR="91440" marT="45720" marB="45720" anchor="ctr">
+                    <a:lnL w="12700" cap="flat" cmpd="sng" algn="ctr">
+                      <a:solidFill>
+                        <a:srgbClr val="CBD5E0"/>
+                      </a:solidFill>
+                      <a:prstDash val="solid"/>
+                      <a:round/>
+                      <a:headEnd type="none" w="med" len="med"/>
+                      <a:tailEnd type="none" w="med" len="med"/>
+                    </a:lnL>
+                    <a:lnR w="12700" cap="flat" cmpd="sng" algn="ctr">
+                      <a:solidFill>
+                        <a:srgbClr val="CBD5E0"/>
+                      </a:solidFill>
+                      <a:prstDash val="solid"/>
+                      <a:round/>
+                      <a:headEnd type="none" w="med" len="med"/>
+                      <a:tailEnd type="none" w="med" len="med"/>
+                    </a:lnR>
+                    <a:lnT w="12700" cap="flat" cmpd="sng" algn="ctr">
+                      <a:solidFill>
+                        <a:srgbClr val="CBD5E0"/>
+                      </a:solidFill>
+                      <a:prstDash val="solid"/>
+                      <a:round/>
+                      <a:headEnd type="none" w="med" len="med"/>
+                      <a:tailEnd type="none" w="med" len="med"/>
+                    </a:lnT>
+                    <a:lnB w="12700" cap="flat" cmpd="sng" algn="ctr">
+                      <a:solidFill>
+                        <a:srgbClr val="CBD5E0"/>
+                      </a:solidFill>
+                      <a:prstDash val="solid"/>
+                      <a:round/>
+                      <a:headEnd type="none" w="med" len="med"/>
+                      <a:tailEnd type="none" w="med" len="med"/>
+                    </a:lnB>
+                    <a:solidFill>
+                      <a:srgbClr val="F3F6F7"/>
+                    </a:solidFill>
+                  </a:tcPr>
+                </a:tc>
+                <a:tc>
+                  <a:txBody>
+                    <a:bodyPr/>
+                    <a:lstStyle/>
+                    <a:p>
+                      <a:pPr algn="ctr" indent="0" marL="0">
+                        <a:buNone/>
+                      </a:pPr>
                       <a:endParaRPr lang="en-US" sz="850" dirty="0">
                         <a:latin typeface="맑은 고딕" charset="0"/>
                         <a:ea typeface="맑은 고딕" charset="0"/>
@@ -11476,74 +11392,6 @@
                           <a:ea typeface="맑은 고딕" pitchFamily="34" charset="-122"/>
                           <a:cs typeface="맑은 고딕" pitchFamily="34" charset="-120"/>
                         </a:rPr>
-                        <a:t>-</a:t>
-                      </a:r>
-                      <a:endParaRPr lang="en-US" sz="850" dirty="0">
-                        <a:latin typeface="맑은 고딕" charset="0"/>
-                        <a:ea typeface="맑은 고딕" charset="0"/>
-                        <a:cs typeface="맑은 고딕" charset="0"/>
-                      </a:endParaRPr>
-                    </a:p>
-                  </a:txBody>
-                  <a:tcPr marL="91440" marR="91440" marT="45720" marB="45720" anchor="ctr">
-                    <a:lnL w="12700" cap="flat" cmpd="sng" algn="ctr">
-                      <a:solidFill>
-                        <a:srgbClr val="CBD5E0"/>
-                      </a:solidFill>
-                      <a:prstDash val="solid"/>
-                      <a:round/>
-                      <a:headEnd type="none" w="med" len="med"/>
-                      <a:tailEnd type="none" w="med" len="med"/>
-                    </a:lnL>
-                    <a:lnR w="12700" cap="flat" cmpd="sng" algn="ctr">
-                      <a:solidFill>
-                        <a:srgbClr val="CBD5E0"/>
-                      </a:solidFill>
-                      <a:prstDash val="solid"/>
-                      <a:round/>
-                      <a:headEnd type="none" w="med" len="med"/>
-                      <a:tailEnd type="none" w="med" len="med"/>
-                    </a:lnR>
-                    <a:lnT w="12700" cap="flat" cmpd="sng" algn="ctr">
-                      <a:solidFill>
-                        <a:srgbClr val="CBD5E0"/>
-                      </a:solidFill>
-                      <a:prstDash val="solid"/>
-                      <a:round/>
-                      <a:headEnd type="none" w="med" len="med"/>
-                      <a:tailEnd type="none" w="med" len="med"/>
-                    </a:lnT>
-                    <a:lnB w="12700" cap="flat" cmpd="sng" algn="ctr">
-                      <a:solidFill>
-                        <a:srgbClr val="CBD5E0"/>
-                      </a:solidFill>
-                      <a:prstDash val="solid"/>
-                      <a:round/>
-                      <a:headEnd type="none" w="med" len="med"/>
-                      <a:tailEnd type="none" w="med" len="med"/>
-                    </a:lnB>
-                    <a:solidFill>
-                      <a:srgbClr val="FFFFFF"/>
-                    </a:solidFill>
-                  </a:tcPr>
-                </a:tc>
-                <a:tc>
-                  <a:txBody>
-                    <a:bodyPr/>
-                    <a:lstStyle/>
-                    <a:p>
-                      <a:pPr algn="ctr" indent="0" marL="0">
-                        <a:buNone/>
-                      </a:pPr>
-                      <a:r>
-                        <a:rPr lang="en-US" sz="850" dirty="0">
-                          <a:solidFill>
-                            <a:srgbClr val="2B2B2B"/>
-                          </a:solidFill>
-                          <a:latin typeface="맑은 고딕" pitchFamily="34" charset="0"/>
-                          <a:ea typeface="맑은 고딕" pitchFamily="34" charset="-122"/>
-                          <a:cs typeface="맑은 고딕" pitchFamily="34" charset="-120"/>
-                        </a:rPr>
                         <a:t>2026-08-31</a:t>
                       </a:r>
                       <a:endParaRPr lang="en-US" sz="850" dirty="0">
@@ -11614,6 +11462,63 @@
                         </a:rPr>
                         <a:t>로뎀나무내과 통합계약</a:t>
                       </a:r>
+                      <a:endParaRPr lang="en-US" sz="850" dirty="0">
+                        <a:latin typeface="맑은 고딕" charset="0"/>
+                        <a:ea typeface="맑은 고딕" charset="0"/>
+                        <a:cs typeface="맑은 고딕" charset="0"/>
+                      </a:endParaRPr>
+                    </a:p>
+                  </a:txBody>
+                  <a:tcPr marL="91440" marR="91440" marT="45720" marB="45720" anchor="ctr">
+                    <a:lnL w="12700" cap="flat" cmpd="sng" algn="ctr">
+                      <a:solidFill>
+                        <a:srgbClr val="CBD5E0"/>
+                      </a:solidFill>
+                      <a:prstDash val="solid"/>
+                      <a:round/>
+                      <a:headEnd type="none" w="med" len="med"/>
+                      <a:tailEnd type="none" w="med" len="med"/>
+                    </a:lnL>
+                    <a:lnR w="12700" cap="flat" cmpd="sng" algn="ctr">
+                      <a:solidFill>
+                        <a:srgbClr val="CBD5E0"/>
+                      </a:solidFill>
+                      <a:prstDash val="solid"/>
+                      <a:round/>
+                      <a:headEnd type="none" w="med" len="med"/>
+                      <a:tailEnd type="none" w="med" len="med"/>
+                    </a:lnR>
+                    <a:lnT w="12700" cap="flat" cmpd="sng" algn="ctr">
+                      <a:solidFill>
+                        <a:srgbClr val="CBD5E0"/>
+                      </a:solidFill>
+                      <a:prstDash val="solid"/>
+                      <a:round/>
+                      <a:headEnd type="none" w="med" len="med"/>
+                      <a:tailEnd type="none" w="med" len="med"/>
+                    </a:lnT>
+                    <a:lnB w="12700" cap="flat" cmpd="sng" algn="ctr">
+                      <a:solidFill>
+                        <a:srgbClr val="CBD5E0"/>
+                      </a:solidFill>
+                      <a:prstDash val="solid"/>
+                      <a:round/>
+                      <a:headEnd type="none" w="med" len="med"/>
+                      <a:tailEnd type="none" w="med" len="med"/>
+                    </a:lnB>
+                    <a:solidFill>
+                      <a:srgbClr val="FFFFFF"/>
+                    </a:solidFill>
+                  </a:tcPr>
+                </a:tc>
+                <a:tc>
+                  <a:txBody>
+                    <a:bodyPr/>
+                    <a:lstStyle/>
+                    <a:p>
+                      <a:pPr algn="ctr" indent="0" marL="0">
+                        <a:buNone/>
+                      </a:pPr>
                       <a:endParaRPr lang="en-US" sz="850" dirty="0">
                         <a:latin typeface="맑은 고딕" charset="0"/>
                         <a:ea typeface="맑은 고딕" charset="0"/>
@@ -12158,74 +12063,6 @@
                           <a:ea typeface="맑은 고딕" pitchFamily="34" charset="-122"/>
                           <a:cs typeface="맑은 고딕" pitchFamily="34" charset="-120"/>
                         </a:rPr>
-                        <a:t>-</a:t>
-                      </a:r>
-                      <a:endParaRPr lang="en-US" sz="850" dirty="0">
-                        <a:latin typeface="맑은 고딕" charset="0"/>
-                        <a:ea typeface="맑은 고딕" charset="0"/>
-                        <a:cs typeface="맑은 고딕" charset="0"/>
-                      </a:endParaRPr>
-                    </a:p>
-                  </a:txBody>
-                  <a:tcPr marL="91440" marR="91440" marT="45720" marB="45720" anchor="ctr">
-                    <a:lnL w="12700" cap="flat" cmpd="sng" algn="ctr">
-                      <a:solidFill>
-                        <a:srgbClr val="CBD5E0"/>
-                      </a:solidFill>
-                      <a:prstDash val="solid"/>
-                      <a:round/>
-                      <a:headEnd type="none" w="med" len="med"/>
-                      <a:tailEnd type="none" w="med" len="med"/>
-                    </a:lnL>
-                    <a:lnR w="12700" cap="flat" cmpd="sng" algn="ctr">
-                      <a:solidFill>
-                        <a:srgbClr val="CBD5E0"/>
-                      </a:solidFill>
-                      <a:prstDash val="solid"/>
-                      <a:round/>
-                      <a:headEnd type="none" w="med" len="med"/>
-                      <a:tailEnd type="none" w="med" len="med"/>
-                    </a:lnR>
-                    <a:lnT w="12700" cap="flat" cmpd="sng" algn="ctr">
-                      <a:solidFill>
-                        <a:srgbClr val="CBD5E0"/>
-                      </a:solidFill>
-                      <a:prstDash val="solid"/>
-                      <a:round/>
-                      <a:headEnd type="none" w="med" len="med"/>
-                      <a:tailEnd type="none" w="med" len="med"/>
-                    </a:lnT>
-                    <a:lnB w="12700" cap="flat" cmpd="sng" algn="ctr">
-                      <a:solidFill>
-                        <a:srgbClr val="CBD5E0"/>
-                      </a:solidFill>
-                      <a:prstDash val="solid"/>
-                      <a:round/>
-                      <a:headEnd type="none" w="med" len="med"/>
-                      <a:tailEnd type="none" w="med" len="med"/>
-                    </a:lnB>
-                    <a:solidFill>
-                      <a:srgbClr val="F3F6F7"/>
-                    </a:solidFill>
-                  </a:tcPr>
-                </a:tc>
-                <a:tc>
-                  <a:txBody>
-                    <a:bodyPr/>
-                    <a:lstStyle/>
-                    <a:p>
-                      <a:pPr algn="ctr" indent="0" marL="0">
-                        <a:buNone/>
-                      </a:pPr>
-                      <a:r>
-                        <a:rPr lang="en-US" sz="850" dirty="0">
-                          <a:solidFill>
-                            <a:srgbClr val="2B2B2B"/>
-                          </a:solidFill>
-                          <a:latin typeface="맑은 고딕" pitchFamily="34" charset="0"/>
-                          <a:ea typeface="맑은 고딕" pitchFamily="34" charset="-122"/>
-                          <a:cs typeface="맑은 고딕" pitchFamily="34" charset="-120"/>
-                        </a:rPr>
                         <a:t>2026-08-31</a:t>
                       </a:r>
                       <a:endParaRPr lang="en-US" sz="850" dirty="0">
@@ -12296,6 +12133,63 @@
                         </a:rPr>
                         <a:t>로뎀나무내과 통합계약</a:t>
                       </a:r>
+                      <a:endParaRPr lang="en-US" sz="850" dirty="0">
+                        <a:latin typeface="맑은 고딕" charset="0"/>
+                        <a:ea typeface="맑은 고딕" charset="0"/>
+                        <a:cs typeface="맑은 고딕" charset="0"/>
+                      </a:endParaRPr>
+                    </a:p>
+                  </a:txBody>
+                  <a:tcPr marL="91440" marR="91440" marT="45720" marB="45720" anchor="ctr">
+                    <a:lnL w="12700" cap="flat" cmpd="sng" algn="ctr">
+                      <a:solidFill>
+                        <a:srgbClr val="CBD5E0"/>
+                      </a:solidFill>
+                      <a:prstDash val="solid"/>
+                      <a:round/>
+                      <a:headEnd type="none" w="med" len="med"/>
+                      <a:tailEnd type="none" w="med" len="med"/>
+                    </a:lnL>
+                    <a:lnR w="12700" cap="flat" cmpd="sng" algn="ctr">
+                      <a:solidFill>
+                        <a:srgbClr val="CBD5E0"/>
+                      </a:solidFill>
+                      <a:prstDash val="solid"/>
+                      <a:round/>
+                      <a:headEnd type="none" w="med" len="med"/>
+                      <a:tailEnd type="none" w="med" len="med"/>
+                    </a:lnR>
+                    <a:lnT w="12700" cap="flat" cmpd="sng" algn="ctr">
+                      <a:solidFill>
+                        <a:srgbClr val="CBD5E0"/>
+                      </a:solidFill>
+                      <a:prstDash val="solid"/>
+                      <a:round/>
+                      <a:headEnd type="none" w="med" len="med"/>
+                      <a:tailEnd type="none" w="med" len="med"/>
+                    </a:lnT>
+                    <a:lnB w="12700" cap="flat" cmpd="sng" algn="ctr">
+                      <a:solidFill>
+                        <a:srgbClr val="CBD5E0"/>
+                      </a:solidFill>
+                      <a:prstDash val="solid"/>
+                      <a:round/>
+                      <a:headEnd type="none" w="med" len="med"/>
+                      <a:tailEnd type="none" w="med" len="med"/>
+                    </a:lnB>
+                    <a:solidFill>
+                      <a:srgbClr val="F3F6F7"/>
+                    </a:solidFill>
+                  </a:tcPr>
+                </a:tc>
+                <a:tc>
+                  <a:txBody>
+                    <a:bodyPr/>
+                    <a:lstStyle/>
+                    <a:p>
+                      <a:pPr algn="ctr" indent="0" marL="0">
+                        <a:buNone/>
+                      </a:pPr>
                       <a:endParaRPr lang="en-US" sz="850" dirty="0">
                         <a:latin typeface="맑은 고딕" charset="0"/>
                         <a:ea typeface="맑은 고딕" charset="0"/>
@@ -12840,7 +12734,7 @@
                           <a:ea typeface="맑은 고딕" pitchFamily="34" charset="-122"/>
                           <a:cs typeface="맑은 고딕" pitchFamily="34" charset="-120"/>
                         </a:rPr>
-                        <a:t>-</a:t>
+                        <a:t>2026-04-17</a:t>
                       </a:r>
                       <a:endParaRPr lang="en-US" sz="850" dirty="0">
                         <a:latin typeface="맑은 고딕" charset="0"/>
@@ -12899,17 +12793,6 @@
                       <a:pPr algn="ctr" indent="0" marL="0">
                         <a:buNone/>
                       </a:pPr>
-                      <a:r>
-                        <a:rPr lang="en-US" sz="850" dirty="0">
-                          <a:solidFill>
-                            <a:srgbClr val="2B2B2B"/>
-                          </a:solidFill>
-                          <a:latin typeface="맑은 고딕" pitchFamily="34" charset="0"/>
-                          <a:ea typeface="맑은 고딕" pitchFamily="34" charset="-122"/>
-                          <a:cs typeface="맑은 고딕" pitchFamily="34" charset="-120"/>
-                        </a:rPr>
-                        <a:t>2026-04-17</a:t>
-                      </a:r>
                       <a:endParaRPr lang="en-US" sz="850" dirty="0">
                         <a:latin typeface="맑은 고딕" charset="0"/>
                         <a:ea typeface="맑은 고딕" charset="0"/>
@@ -13511,7 +13394,7 @@
                           <a:ea typeface="맑은 고딕" pitchFamily="34" charset="-122"/>
                           <a:cs typeface="맑은 고딕" pitchFamily="34" charset="-120"/>
                         </a:rPr>
-                        <a:t>-</a:t>
+                        <a:t>2025-04-30</a:t>
                       </a:r>
                       <a:endParaRPr lang="en-US" sz="850" dirty="0">
                         <a:latin typeface="맑은 고딕" charset="0"/>
@@ -13570,17 +13453,6 @@
                       <a:pPr algn="ctr" indent="0" marL="0">
                         <a:buNone/>
                       </a:pPr>
-                      <a:r>
-                        <a:rPr lang="en-US" sz="850" dirty="0">
-                          <a:solidFill>
-                            <a:srgbClr val="2B2B2B"/>
-                          </a:solidFill>
-                          <a:latin typeface="맑은 고딕" pitchFamily="34" charset="0"/>
-                          <a:ea typeface="맑은 고딕" pitchFamily="34" charset="-122"/>
-                          <a:cs typeface="맑은 고딕" pitchFamily="34" charset="-120"/>
-                        </a:rPr>
-                        <a:t>2025-04-30</a:t>
-                      </a:r>
                       <a:endParaRPr lang="en-US" sz="850" dirty="0">
                         <a:latin typeface="맑은 고딕" charset="0"/>
                         <a:ea typeface="맑은 고딕" charset="0"/>
@@ -14250,7 +14122,7 @@
                           <a:ea typeface="맑은 고딕" pitchFamily="34" charset="-122"/>
                           <a:cs typeface="맑은 고딕" pitchFamily="34" charset="-120"/>
                         </a:rPr>
-                        <a:t>-</a:t>
+                        <a:t>자가사용</a:t>
                       </a:r>
                       <a:endParaRPr lang="en-US" sz="850" dirty="0">
                         <a:latin typeface="맑은 고딕" charset="0"/>
@@ -14309,17 +14181,6 @@
                       <a:pPr algn="ctr" indent="0" marL="0">
                         <a:buNone/>
                       </a:pPr>
-                      <a:r>
-                        <a:rPr lang="en-US" sz="850" dirty="0">
-                          <a:solidFill>
-                            <a:srgbClr val="5B6B73"/>
-                          </a:solidFill>
-                          <a:latin typeface="맑은 고딕" pitchFamily="34" charset="0"/>
-                          <a:ea typeface="맑은 고딕" pitchFamily="34" charset="-122"/>
-                          <a:cs typeface="맑은 고딕" pitchFamily="34" charset="-120"/>
-                        </a:rPr>
-                        <a:t>자가사용</a:t>
-                      </a:r>
                       <a:endParaRPr lang="en-US" sz="850" dirty="0">
                         <a:latin typeface="맑은 고딕" charset="0"/>
                         <a:ea typeface="맑은 고딕" charset="0"/>
@@ -14864,74 +14725,6 @@
                           <a:ea typeface="맑은 고딕" pitchFamily="34" charset="-122"/>
                           <a:cs typeface="맑은 고딕" pitchFamily="34" charset="-120"/>
                         </a:rPr>
-                        <a:t>-</a:t>
-                      </a:r>
-                      <a:endParaRPr lang="en-US" sz="850" dirty="0">
-                        <a:latin typeface="맑은 고딕" charset="0"/>
-                        <a:ea typeface="맑은 고딕" charset="0"/>
-                        <a:cs typeface="맑은 고딕" charset="0"/>
-                      </a:endParaRPr>
-                    </a:p>
-                  </a:txBody>
-                  <a:tcPr marL="91440" marR="91440" marT="45720" marB="45720" anchor="ctr">
-                    <a:lnL w="12700" cap="flat" cmpd="sng" algn="ctr">
-                      <a:solidFill>
-                        <a:srgbClr val="CBD5E0"/>
-                      </a:solidFill>
-                      <a:prstDash val="solid"/>
-                      <a:round/>
-                      <a:headEnd type="none" w="med" len="med"/>
-                      <a:tailEnd type="none" w="med" len="med"/>
-                    </a:lnL>
-                    <a:lnR w="12700" cap="flat" cmpd="sng" algn="ctr">
-                      <a:solidFill>
-                        <a:srgbClr val="CBD5E0"/>
-                      </a:solidFill>
-                      <a:prstDash val="solid"/>
-                      <a:round/>
-                      <a:headEnd type="none" w="med" len="med"/>
-                      <a:tailEnd type="none" w="med" len="med"/>
-                    </a:lnR>
-                    <a:lnT w="12700" cap="flat" cmpd="sng" algn="ctr">
-                      <a:solidFill>
-                        <a:srgbClr val="CBD5E0"/>
-                      </a:solidFill>
-                      <a:prstDash val="solid"/>
-                      <a:round/>
-                      <a:headEnd type="none" w="med" len="med"/>
-                      <a:tailEnd type="none" w="med" len="med"/>
-                    </a:lnT>
-                    <a:lnB w="12700" cap="flat" cmpd="sng" algn="ctr">
-                      <a:solidFill>
-                        <a:srgbClr val="CBD5E0"/>
-                      </a:solidFill>
-                      <a:prstDash val="solid"/>
-                      <a:round/>
-                      <a:headEnd type="none" w="med" len="med"/>
-                      <a:tailEnd type="none" w="med" len="med"/>
-                    </a:lnB>
-                    <a:solidFill>
-                      <a:srgbClr val="F3F6F7"/>
-                    </a:solidFill>
-                  </a:tcPr>
-                </a:tc>
-                <a:tc>
-                  <a:txBody>
-                    <a:bodyPr/>
-                    <a:lstStyle/>
-                    <a:p>
-                      <a:pPr algn="ctr" indent="0" marL="0">
-                        <a:buNone/>
-                      </a:pPr>
-                      <a:r>
-                        <a:rPr lang="en-US" sz="850" dirty="0">
-                          <a:solidFill>
-                            <a:srgbClr val="2B2B2B"/>
-                          </a:solidFill>
-                          <a:latin typeface="맑은 고딕" pitchFamily="34" charset="0"/>
-                          <a:ea typeface="맑은 고딕" pitchFamily="34" charset="-122"/>
-                          <a:cs typeface="맑은 고딕" pitchFamily="34" charset="-120"/>
-                        </a:rPr>
                         <a:t>2026-08-31</a:t>
                       </a:r>
                       <a:endParaRPr lang="en-US" sz="850" dirty="0">
@@ -15002,6 +14795,63 @@
                         </a:rPr>
                         <a:t>로뎀나무내과 통합계약</a:t>
                       </a:r>
+                      <a:endParaRPr lang="en-US" sz="850" dirty="0">
+                        <a:latin typeface="맑은 고딕" charset="0"/>
+                        <a:ea typeface="맑은 고딕" charset="0"/>
+                        <a:cs typeface="맑은 고딕" charset="0"/>
+                      </a:endParaRPr>
+                    </a:p>
+                  </a:txBody>
+                  <a:tcPr marL="91440" marR="91440" marT="45720" marB="45720" anchor="ctr">
+                    <a:lnL w="12700" cap="flat" cmpd="sng" algn="ctr">
+                      <a:solidFill>
+                        <a:srgbClr val="CBD5E0"/>
+                      </a:solidFill>
+                      <a:prstDash val="solid"/>
+                      <a:round/>
+                      <a:headEnd type="none" w="med" len="med"/>
+                      <a:tailEnd type="none" w="med" len="med"/>
+                    </a:lnL>
+                    <a:lnR w="12700" cap="flat" cmpd="sng" algn="ctr">
+                      <a:solidFill>
+                        <a:srgbClr val="CBD5E0"/>
+                      </a:solidFill>
+                      <a:prstDash val="solid"/>
+                      <a:round/>
+                      <a:headEnd type="none" w="med" len="med"/>
+                      <a:tailEnd type="none" w="med" len="med"/>
+                    </a:lnR>
+                    <a:lnT w="12700" cap="flat" cmpd="sng" algn="ctr">
+                      <a:solidFill>
+                        <a:srgbClr val="CBD5E0"/>
+                      </a:solidFill>
+                      <a:prstDash val="solid"/>
+                      <a:round/>
+                      <a:headEnd type="none" w="med" len="med"/>
+                      <a:tailEnd type="none" w="med" len="med"/>
+                    </a:lnT>
+                    <a:lnB w="12700" cap="flat" cmpd="sng" algn="ctr">
+                      <a:solidFill>
+                        <a:srgbClr val="CBD5E0"/>
+                      </a:solidFill>
+                      <a:prstDash val="solid"/>
+                      <a:round/>
+                      <a:headEnd type="none" w="med" len="med"/>
+                      <a:tailEnd type="none" w="med" len="med"/>
+                    </a:lnB>
+                    <a:solidFill>
+                      <a:srgbClr val="F3F6F7"/>
+                    </a:solidFill>
+                  </a:tcPr>
+                </a:tc>
+                <a:tc>
+                  <a:txBody>
+                    <a:bodyPr/>
+                    <a:lstStyle/>
+                    <a:p>
+                      <a:pPr algn="ctr" indent="0" marL="0">
+                        <a:buNone/>
+                      </a:pPr>
                       <a:endParaRPr lang="en-US" sz="850" dirty="0">
                         <a:latin typeface="맑은 고딕" charset="0"/>
                         <a:ea typeface="맑은 고딕" charset="0"/>

</xml_diff>